<commit_message>
Update final report and presentation
</commit_message>
<xml_diff>
--- a/presentation/presentation.pptx
+++ b/presentation/presentation.pptx
@@ -5608,17 +5608,61 @@
               <a:buNone/>
             </a:pPr>
             <a:r>
+              <a:rPr lang="en-US" sz="1000" dirty="0" smtClean="0">
+                <a:solidFill>
+                  <a:srgbClr val="1A7A8A"/>
+                </a:solidFill>
+                <a:latin typeface="Arial" pitchFamily="34" charset="0"/>
+                <a:ea typeface="Arial" pitchFamily="34" charset="-122"/>
+                <a:cs typeface="Arial" pitchFamily="34" charset="-120"/>
+              </a:rPr>
+              <a:t>github.com/</a:t>
+            </a:r>
+            <a:r>
+              <a:rPr lang="en-US" sz="1000" dirty="0" err="1" smtClean="0">
+                <a:solidFill>
+                  <a:srgbClr val="1A7A8A"/>
+                </a:solidFill>
+                <a:latin typeface="Arial" pitchFamily="34" charset="0"/>
+                <a:ea typeface="Arial" pitchFamily="34" charset="-122"/>
+                <a:cs typeface="Arial" pitchFamily="34" charset="-120"/>
+              </a:rPr>
+              <a:t>beyzaucarr</a:t>
+            </a:r>
+            <a:r>
+              <a:rPr lang="en-US" sz="1000" dirty="0" smtClean="0">
+                <a:solidFill>
+                  <a:srgbClr val="1A7A8A"/>
+                </a:solidFill>
+                <a:latin typeface="Arial" pitchFamily="34" charset="0"/>
+                <a:ea typeface="Arial" pitchFamily="34" charset="-122"/>
+                <a:cs typeface="Arial" pitchFamily="34" charset="-120"/>
+              </a:rPr>
+              <a:t>/Healthcare-Diagnosis-Ontology</a:t>
+            </a:r>
+            <a:endParaRPr lang="tr-TR" sz="1000" dirty="0" smtClean="0">
+              <a:solidFill>
+                <a:srgbClr val="1A7A8A"/>
+              </a:solidFill>
+              <a:latin typeface="Arial" pitchFamily="34" charset="0"/>
+              <a:ea typeface="Arial" pitchFamily="34" charset="-122"/>
+              <a:cs typeface="Arial" pitchFamily="34" charset="-120"/>
+            </a:endParaRPr>
+          </a:p>
+          <a:p>
+            <a:r>
               <a:rPr lang="en-US" sz="1000" dirty="0">
                 <a:solidFill>
-                  <a:srgbClr val="1A7A8A"/>
-                </a:solidFill>
-                <a:latin typeface="Arial" pitchFamily="34" charset="0"/>
-                <a:ea typeface="Arial" pitchFamily="34" charset="-122"/>
-                <a:cs typeface="Arial" pitchFamily="34" charset="-120"/>
-              </a:rPr>
-              <a:t>github.com/beyzaucarr/Healthcare-Diagnosis-Ontology</a:t>
-            </a:r>
-            <a:endParaRPr lang="en-US" sz="1000" dirty="0"/>
+                  <a:srgbClr val="C00000"/>
+                </a:solidFill>
+              </a:rPr>
+              <a:t>https://beyzaucarr.github.io/Healthcare-Diagnosis-Ontology/widoco-docs/</a:t>
+            </a:r>
+            <a:endParaRPr lang="en-US" sz="1000" dirty="0">
+              <a:solidFill>
+                <a:srgbClr val="C00000"/>
+              </a:solidFill>
+            </a:endParaRPr>
           </a:p>
         </p:txBody>
       </p:sp>
@@ -18526,7 +18570,7 @@
   <a:extraClrSchemeLst/>
   <a:extLst>
     <a:ext uri="{05A4C25C-085E-4340-85A3-A5531E510DB2}">
-      <thm15:themeFamily xmlns:thm15="http://schemas.microsoft.com/office/thememl/2012/main" xmlns="" name="Office Theme" id="{62F939B6-93AF-4DB8-9C6B-D6C7DFDC589F}" vid="{4A3C46E8-61CC-4603-A589-7422A47A8E4A}"/>
+      <thm15:themeFamily xmlns="" xmlns:thm15="http://schemas.microsoft.com/office/thememl/2012/main" name="Office Theme" id="{62F939B6-93AF-4DB8-9C6B-D6C7DFDC589F}" vid="{4A3C46E8-61CC-4603-A589-7422A47A8E4A}"/>
     </a:ext>
   </a:extLst>
 </a:theme>

</xml_diff>